<commit_message>
Ngữ văn Bài 3 (10, 11, 12): đối chiếu SGV, bổ sung Củng cố – mở rộng, Thực hành đọc, bảng đánh giá theo SGK
Co-Authored-By: Claude Opus 5.5 <noreply@anthropic.com>
</commit_message>
<xml_diff>
--- a/mon/ngu_van/slide/lop10/Slide_NGUVAN10_Bai3_NgheThuatThuyetPhucTrongVanNghiLuan_T23-35.pptx
+++ b/mon/ngu_van/slide/lop10/Slide_NGUVAN10_Bai3_NgheThuatThuyetPhucTrongVanNghiLuan_T23-35.pptx
@@ -6081,7 +6081,7 @@
                 </a:solidFill>
                 <a:latin typeface="Calibri"/>
               </a:rPr>
-              <a:t>💡 Đọc kĩ đoạn 5.</a:t>
+              <a:t>💡 Đọc kĩ đoạn 3.</a:t>
             </a:r>
           </a:p>
         </p:txBody>
@@ -6382,7 +6382,7 @@
                 </a:solidFill>
                 <a:latin typeface="Calibri"/>
               </a:rPr>
-              <a:t>Mục đích: “kẻ ác lấy đó làm răn, người thiện theo đó mà gắng, dẫn việc dĩ vãng, chỉ lối tương lai,</a:t>
+              <a:t>Mục đích (đoạn 3): “…lời khen tiếng thơm chưa đủ lưu vẻ sáng lâu dài, cho nên lại dựng đá đề danh…</a:t>
             </a:r>
           </a:p>
           <a:p>
@@ -6403,7 +6403,7 @@
                 </a:solidFill>
                 <a:latin typeface="Calibri"/>
               </a:rPr>
-              <a:t>vừa để rèn giũa danh tiếng cho sĩ phu, vừa để củng cố mệnh mạch cho nhà nước”.</a:t>
+              <a:t>…khiến cho kẻ sĩ trông vào mà phấn chấn hâm mộ, rèn luyện danh tiết, gắng sức giúp vua”.</a:t>
             </a:r>
           </a:p>
         </p:txBody>
@@ -7132,7 +7132,7 @@
                 </a:solidFill>
                 <a:latin typeface="Calibri"/>
               </a:rPr>
-              <a:t>Đoạn 3 tiếp nối, nâng cao đoạn 2: khen thưởng chưa đủ → dựng đá đề danh để lưu truyền lâu dài.</a:t>
+              <a:t>Đoạn 3 triển khai thêm ý trọng đãi hiền tài ở đoạn 2: chuyển từ nguyên lí chung sang chuyện dựng bia.</a:t>
             </a:r>
           </a:p>
           <a:p>
@@ -7153,28 +7153,7 @@
                 </a:solidFill>
                 <a:latin typeface="Calibri"/>
               </a:rPr>
-              <a:t>Đoạn 4: trách nhiệm của kẻ sĩ phải “tự trọng tấm thân mà ra sức báo đáp”.</a:t>
-            </a:r>
-          </a:p>
-          <a:p>
-            <a:pPr algn="l" marL="365760" indent="-365760">
-              <a:spcAft>
-                <a:spcPts val="800"/>
-              </a:spcAft>
-              <a:buClr>
-                <a:srgbClr val="1E40AF"/>
-              </a:buClr>
-              <a:buFont typeface="Arial"/>
-              <a:buChar char="•"/>
-            </a:pPr>
-            <a:r>
-              <a:rPr sz="2300">
-                <a:solidFill>
-                  <a:srgbClr val="1E293B"/>
-                </a:solidFill>
-                <a:latin typeface="Calibri"/>
-              </a:rPr>
-              <a:t>Đoạn 4 là cầu nối chuyển sang ý nghĩa của tấm bia (đoạn 5).</a:t>
+              <a:t>Đoạn 4: lời tự vấn – thái độ tự trọng của kẻ sĩ; bước chuyển sang lời khuyến cáo (đoạn 5).</a:t>
             </a:r>
           </a:p>
         </p:txBody>

</xml_diff>